<commit_message>
Founder slide: reframe around Bridge Nurse founder-market fit
Co-Authored-By: Claude Opus 5.5 <noreply@anthropic.com>
Claude-Session: https://claude.ai/code/session_01StTNeBEfEL1qu9q7jAwWu4
</commit_message>
<xml_diff>
--- a/Founder_Slide_v2.pptx
+++ b/Founder_Slide_v2.pptx
@@ -502,7 +502,8 @@
           <a:p>
             <a:r>
               <a:rPr lang="en-US" dirty="0"/>
-              <a:t>Founder roles and backgrounds as represented by management. Founder names link to their professional profiles.
+              <a:t>Message: this team has already done the hardest parts of Bridge Nurse: recruiting and deploying a workforce at scale (21,000+ between Sutanu and Rahul), opening healthcare corridors abroad (Sutanu, RG Medicare: Bangladesh and Oman), and running Big 4-grade finance and governance (Vaibhav). Nurse education is the gap, which is why it leads the hiring plan.
+Founder roles and backgrounds as represented by management. Founder names link to their professional profiles.
 Sutanu Dutta (19 years; ex-Truxapp, Rivigo, HT Media, Peel Works; 1x founder) and Rahul Luthra (9 years; ex-Swiggy; 2x founder) are full-time. Vaibhav Kedia joins full-time at close and is a Director at EY until then. Senior technology / AI, nurse-education and operations candidates are in discussion. No offers have been accepted.
 Sources: each founder's résumé or professional profile, supplied by the founder. Not independently verified. Sutanu's rupee figures at ₹95/$: staffing revenue ₹20 Cr to ₹106 Cr ($2M to $11M, 5.3×); ₹150 Cr of contracted value ($16M); ₹240 Cr distribution P&amp;L ($25M). Vaibhav's 19 years at EY include 3 years as an intern; clients include Amazon, Airtel, ITC, Siemens, Intel, Epson and Happiest Minds. Rahul's 10,000+ onboarding and 98.6% serviceability are from his Swiggy role (2019–2023).</a:t>
             </a:r>
@@ -886,7 +887,7 @@
         <p:spPr>
           <a:xfrm>
             <a:off x="457200" y="347472"/>
-            <a:ext cx="5486400" cy="228600"/>
+            <a:ext cx="7315200" cy="228600"/>
           </a:xfrm>
           <a:prstGeom prst="rect">
             <a:avLst/>
@@ -910,7 +911,7 @@
                 <a:ea typeface="Calibri" pitchFamily="34" charset="-122"/>
                 <a:cs typeface="Calibri" pitchFamily="34" charset="-120"/>
               </a:rPr>
-              <a:t>THE FOUNDING TEAM</a:t>
+              <a:t>WHY THIS TEAM WINS AT BRIDGE NURSE</a:t>
             </a:r>
             <a:endParaRPr lang="en-US" sz="1100" dirty="0"/>
           </a:p>
@@ -949,7 +950,7 @@
                 <a:ea typeface="Georgia" pitchFamily="34" charset="-122"/>
                 <a:cs typeface="Georgia" pitchFamily="34" charset="-120"/>
               </a:rPr>
-              <a:t>47 years</a:t>
+              <a:t>We have already done</a:t>
             </a:r>
             <a:pPr indent="0" marL="0">
               <a:buNone/>
@@ -963,7 +964,7 @@
                 <a:ea typeface="Georgia" pitchFamily="34" charset="-122"/>
                 <a:cs typeface="Georgia" pitchFamily="34" charset="-120"/>
               </a:rPr>
-              <a:t> of scale, financial rigor and 0→1 execution</a:t>
+              <a:t> the hardest parts of Bridge Nurse</a:t>
             </a:r>
             <a:endParaRPr lang="en-US" sz="3000" dirty="0"/>
           </a:p>
@@ -1002,7 +1003,7 @@
                 <a:ea typeface="Calibri" pitchFamily="34" charset="-122"/>
                 <a:cs typeface="Calibri" pitchFamily="34" charset="-120"/>
               </a:rPr>
-              <a:t>Two operators who have each put 10,000+ workers to work, and a finance leader who rose from intern to Director at EY</a:t>
+              <a:t>21,000+ workers recruited and deployed. Healthcare corridors opened abroad. Fortune Top 10 audits led. Now we do it for nurses.</a:t>
             </a:r>
             <a:endParaRPr lang="en-US" sz="1400" dirty="0"/>
           </a:p>
@@ -1124,7 +1125,7 @@
                 <a:ea typeface="Calibri" pitchFamily="34" charset="-122"/>
                 <a:cs typeface="Calibri" pitchFamily="34" charset="-120"/>
               </a:rPr>
-              <a:t>THE SCALE OPERATOR</a:t>
+              <a:t>LEADS OPS &amp; CORRIDORS</a:t>
             </a:r>
             <a:endParaRPr lang="en-US" sz="900" dirty="0"/>
           </a:p>
@@ -1258,14 +1259,94 @@
       </p:sp>
       <p:sp>
         <p:nvSpPr>
-          <p:cNvPr id="12" name="Text 9"/>
-          <p:cNvSpPr txBox="1"/>
-          <p:nvPr/>
-        </p:nvSpPr>
-        <p:spPr>
-          <a:xfrm>
-            <a:off x="685800" y="3081528"/>
-            <a:ext cx="1545336" cy="457200"/>
+          <p:cNvPr id="12" name="Shape 9"/>
+          <p:cNvSpPr/>
+          <p:nvPr/>
+        </p:nvSpPr>
+        <p:spPr>
+          <a:xfrm>
+            <a:off x="685800" y="3017520"/>
+            <a:ext cx="3182112" cy="566928"/>
+          </a:xfrm>
+          <a:prstGeom prst="roundRect">
+            <a:avLst>
+              <a:gd name="adj" fmla="val 12903"/>
+            </a:avLst>
+          </a:prstGeom>
+          <a:solidFill>
+            <a:srgbClr val="1C3A63"/>
+          </a:solidFill>
+          <a:ln w="12700">
+            <a:solidFill>
+              <a:srgbClr val="2EC4B0"/>
+            </a:solidFill>
+            <a:prstDash val="solid"/>
+          </a:ln>
+        </p:spPr>
+      </p:sp>
+      <p:sp>
+        <p:nvSpPr>
+          <p:cNvPr id="13" name="Text 10"/>
+          <p:cNvSpPr txBox="1"/>
+          <p:nvPr/>
+        </p:nvSpPr>
+        <p:spPr>
+          <a:xfrm>
+            <a:off x="795528" y="3063240"/>
+            <a:ext cx="2962656" cy="475488"/>
+          </a:xfrm>
+          <a:prstGeom prst="rect">
+            <a:avLst/>
+          </a:prstGeom>
+          <a:noFill/>
+          <a:ln/>
+        </p:spPr>
+        <p:txBody>
+          <a:bodyPr wrap="square" lIns="0" tIns="0" rIns="0" bIns="0" rtlCol="0" anchor="ctr"/>
+          <a:lstStyle/>
+          <a:p>
+            <a:pPr indent="0" marL="0">
+              <a:buNone/>
+            </a:pPr>
+            <a:r>
+              <a:rPr lang="en-US" sz="850" b="1" spc="100" kern="0" dirty="0">
+                <a:solidFill>
+                  <a:srgbClr val="2EC4B0"/>
+                </a:solidFill>
+                <a:latin typeface="Calibri" pitchFamily="34" charset="0"/>
+                <a:ea typeface="Calibri" pitchFamily="34" charset="-122"/>
+                <a:cs typeface="Calibri" pitchFamily="34" charset="-120"/>
+              </a:rPr>
+              <a:t>AT BRIDGE NURSE  </a:t>
+            </a:r>
+            <a:pPr indent="0" marL="0">
+              <a:buNone/>
+            </a:pPr>
+            <a:r>
+              <a:rPr lang="en-US" sz="1050" i="1" dirty="0">
+                <a:solidFill>
+                  <a:srgbClr val="FFFFFF"/>
+                </a:solidFill>
+                <a:latin typeface="Calibri" pitchFamily="34" charset="0"/>
+                <a:ea typeface="Calibri" pitchFamily="34" charset="-122"/>
+                <a:cs typeface="Calibri" pitchFamily="34" charset="-120"/>
+              </a:rPr>
+              <a:t>Has built a workforce engine and healthcare corridors abroad. Now runs both for Bridge Nurse.</a:t>
+            </a:r>
+            <a:endParaRPr lang="en-US" sz="1050" dirty="0"/>
+          </a:p>
+        </p:txBody>
+      </p:sp>
+      <p:sp>
+        <p:nvSpPr>
+          <p:cNvPr id="14" name="Text 11"/>
+          <p:cNvSpPr txBox="1"/>
+          <p:nvPr/>
+        </p:nvSpPr>
+        <p:spPr>
+          <a:xfrm>
+            <a:off x="685800" y="3675888"/>
+            <a:ext cx="1545336" cy="411480"/>
           </a:xfrm>
           <a:prstGeom prst="rect">
             <a:avLst/>
@@ -1297,14 +1378,14 @@
       </p:sp>
       <p:sp>
         <p:nvSpPr>
-          <p:cNvPr id="13" name="Text 10"/>
-          <p:cNvSpPr txBox="1"/>
-          <p:nvPr/>
-        </p:nvSpPr>
-        <p:spPr>
-          <a:xfrm>
-            <a:off x="685800" y="3538728"/>
-            <a:ext cx="1545336" cy="329184"/>
+          <p:cNvPr id="15" name="Text 12"/>
+          <p:cNvSpPr txBox="1"/>
+          <p:nvPr/>
+        </p:nvSpPr>
+        <p:spPr>
+          <a:xfrm>
+            <a:off x="685800" y="4087368"/>
+            <a:ext cx="1545336" cy="310896"/>
           </a:xfrm>
           <a:prstGeom prst="rect">
             <a:avLst/>
@@ -1328,7 +1409,7 @@
                 <a:ea typeface="Calibri" pitchFamily="34" charset="-122"/>
                 <a:cs typeface="Calibri" pitchFamily="34" charset="-120"/>
               </a:rPr>
-              <a:t>associates deployed</a:t>
+              <a:t>associates deployed, full P&amp;L</a:t>
             </a:r>
             <a:endParaRPr lang="en-US" sz="1000" dirty="0"/>
           </a:p>
@@ -1336,14 +1417,14 @@
       </p:sp>
       <p:sp>
         <p:nvSpPr>
-          <p:cNvPr id="14" name="Text 11"/>
-          <p:cNvSpPr txBox="1"/>
-          <p:nvPr/>
-        </p:nvSpPr>
-        <p:spPr>
-          <a:xfrm>
-            <a:off x="2322576" y="3081528"/>
-            <a:ext cx="1545336" cy="457200"/>
+          <p:cNvPr id="16" name="Text 13"/>
+          <p:cNvSpPr txBox="1"/>
+          <p:nvPr/>
+        </p:nvSpPr>
+        <p:spPr>
+          <a:xfrm>
+            <a:off x="2322576" y="3675888"/>
+            <a:ext cx="1545336" cy="411480"/>
           </a:xfrm>
           <a:prstGeom prst="rect">
             <a:avLst/>
@@ -1375,14 +1456,14 @@
       </p:sp>
       <p:sp>
         <p:nvSpPr>
-          <p:cNvPr id="15" name="Text 12"/>
-          <p:cNvSpPr txBox="1"/>
-          <p:nvPr/>
-        </p:nvSpPr>
-        <p:spPr>
-          <a:xfrm>
-            <a:off x="2322576" y="3538728"/>
-            <a:ext cx="1545336" cy="329184"/>
+          <p:cNvPr id="17" name="Text 14"/>
+          <p:cNvSpPr txBox="1"/>
+          <p:nvPr/>
+        </p:nvSpPr>
+        <p:spPr>
+          <a:xfrm>
+            <a:off x="2322576" y="4087368"/>
+            <a:ext cx="1545336" cy="310896"/>
           </a:xfrm>
           <a:prstGeom prst="rect">
             <a:avLst/>
@@ -1406,7 +1487,7 @@
                 <a:ea typeface="Calibri" pitchFamily="34" charset="-122"/>
                 <a:cs typeface="Calibri" pitchFamily="34" charset="-120"/>
               </a:rPr>
-              <a:t>staffing revenue, $2M → $11M</a:t>
+              <a:t>revenue scaled, $2M → $11M</a:t>
             </a:r>
             <a:endParaRPr lang="en-US" sz="1000" dirty="0"/>
           </a:p>
@@ -1414,13 +1495,13 @@
       </p:sp>
       <p:sp>
         <p:nvSpPr>
-          <p:cNvPr id="16" name="Text 13"/>
-          <p:cNvSpPr txBox="1"/>
-          <p:nvPr/>
-        </p:nvSpPr>
-        <p:spPr>
-          <a:xfrm>
-            <a:off x="685800" y="3959352"/>
+          <p:cNvPr id="18" name="Text 15"/>
+          <p:cNvSpPr txBox="1"/>
+          <p:nvPr/>
+        </p:nvSpPr>
+        <p:spPr>
+          <a:xfrm>
+            <a:off x="685800" y="4434840"/>
             <a:ext cx="3182112" cy="164592"/>
           </a:xfrm>
           <a:prstGeom prst="rect">
@@ -1453,13 +1534,13 @@
       </p:sp>
       <p:sp>
         <p:nvSpPr>
-          <p:cNvPr id="17" name="Text 14"/>
-          <p:cNvSpPr txBox="1"/>
-          <p:nvPr/>
-        </p:nvSpPr>
-        <p:spPr>
-          <a:xfrm>
-            <a:off x="685800" y="4123944"/>
+          <p:cNvPr id="19" name="Text 16"/>
+          <p:cNvSpPr txBox="1"/>
+          <p:nvPr/>
+        </p:nvSpPr>
+        <p:spPr>
+          <a:xfrm>
+            <a:off x="685800" y="4590288"/>
             <a:ext cx="3182112" cy="384048"/>
           </a:xfrm>
           <a:prstGeom prst="rect">
@@ -1492,14 +1573,14 @@
       </p:sp>
       <p:sp>
         <p:nvSpPr>
-          <p:cNvPr id="18" name="Text 15"/>
-          <p:cNvSpPr txBox="1"/>
-          <p:nvPr/>
-        </p:nvSpPr>
-        <p:spPr>
-          <a:xfrm>
-            <a:off x="685800" y="4526280"/>
-            <a:ext cx="3182112" cy="896112"/>
+          <p:cNvPr id="20" name="Text 17"/>
+          <p:cNvSpPr txBox="1"/>
+          <p:nvPr/>
+        </p:nvSpPr>
+        <p:spPr>
+          <a:xfrm>
+            <a:off x="685800" y="4983480"/>
+            <a:ext cx="3182112" cy="676656"/>
           </a:xfrm>
           <a:prstGeom prst="rect">
             <a:avLst/>
@@ -1527,7 +1608,7 @@
                 <a:ea typeface="Calibri" pitchFamily="34" charset="-122"/>
                 <a:cs typeface="Calibri" pitchFamily="34" charset="-120"/>
               </a:rPr>
-              <a:t>Won $16M contracted value from Reliance &amp; ITC; ran a $25M distribution P&amp;L</a:t>
+              <a:t>Co-founded RG Medicare (medical tourism): 8 JCI-accredited hospital partners; opened Bangladesh &amp; Oman</a:t>
             </a:r>
             <a:endParaRPr lang="en-US" sz="1000" dirty="0"/>
           </a:p>
@@ -1548,43 +1629,22 @@
                 <a:ea typeface="Calibri" pitchFamily="34" charset="-122"/>
                 <a:cs typeface="Calibri" pitchFamily="34" charset="-120"/>
               </a:rPr>
-              <a:t>1x founder: RG Medicare, opened Bangladesh &amp; Oman corridors</a:t>
+              <a:t>Won $16M from Reliance &amp; ITC; ran a $25M distribution P&amp;L</a:t>
             </a:r>
             <a:endParaRPr lang="en-US" sz="1000" dirty="0"/>
           </a:p>
-          <a:p>
-            <a:pPr marL="152400" indent="-152400">
-              <a:spcAft>
-                <a:spcPts val="300"/>
-              </a:spcAft>
-              <a:buSzPct val="100000"/>
-              <a:buChar char="•"/>
-            </a:pPr>
-            <a:r>
-              <a:rPr lang="en-US" sz="1000" dirty="0">
-                <a:solidFill>
-                  <a:srgbClr val="B9C7DD"/>
-                </a:solidFill>
-                <a:latin typeface="Calibri" pitchFamily="34" charset="0"/>
-                <a:ea typeface="Calibri" pitchFamily="34" charset="-122"/>
-                <a:cs typeface="Calibri" pitchFamily="34" charset="-120"/>
-              </a:rPr>
-              <a:t>On core team that closed a $2.4M seed from Elevar Equity</a:t>
-            </a:r>
-            <a:endParaRPr lang="en-US" sz="1000" dirty="0"/>
-          </a:p>
-        </p:txBody>
-      </p:sp>
-      <p:sp>
-        <p:nvSpPr>
-          <p:cNvPr id="19" name="Text 16"/>
-          <p:cNvSpPr txBox="1"/>
-          <p:nvPr/>
-        </p:nvSpPr>
-        <p:spPr>
-          <a:xfrm>
-            <a:off x="685800" y="5458968"/>
-            <a:ext cx="1165860" cy="237744"/>
+        </p:txBody>
+      </p:sp>
+      <p:sp>
+        <p:nvSpPr>
+          <p:cNvPr id="21" name="Text 18"/>
+          <p:cNvSpPr txBox="1"/>
+          <p:nvPr/>
+        </p:nvSpPr>
+        <p:spPr>
+          <a:xfrm>
+            <a:off x="685800" y="5715000"/>
+            <a:ext cx="973836" cy="237744"/>
           </a:xfrm>
           <a:prstGeom prst="roundRect">
             <a:avLst>
@@ -1624,14 +1684,14 @@
       </p:sp>
       <p:sp>
         <p:nvSpPr>
-          <p:cNvPr id="20" name="Text 17"/>
-          <p:cNvSpPr txBox="1"/>
-          <p:nvPr/>
-        </p:nvSpPr>
-        <p:spPr>
-          <a:xfrm>
-            <a:off x="1924812" y="5458968"/>
-            <a:ext cx="1234440" cy="237744"/>
+          <p:cNvPr id="22" name="Text 19"/>
+          <p:cNvSpPr txBox="1"/>
+          <p:nvPr/>
+        </p:nvSpPr>
+        <p:spPr>
+          <a:xfrm>
+            <a:off x="1732788" y="5715000"/>
+            <a:ext cx="1152144" cy="237744"/>
           </a:xfrm>
           <a:prstGeom prst="roundRect">
             <a:avLst>
@@ -1663,7 +1723,7 @@
                 <a:ea typeface="Calibri" pitchFamily="34" charset="-122"/>
                 <a:cs typeface="Calibri" pitchFamily="34" charset="-120"/>
               </a:rPr>
-              <a:t>Ops Leadership</a:t>
+              <a:t>Cross-Border Ops</a:t>
             </a:r>
             <a:endParaRPr lang="en-US" sz="950" dirty="0"/>
           </a:p>
@@ -1671,14 +1731,14 @@
       </p:sp>
       <p:sp>
         <p:nvSpPr>
-          <p:cNvPr id="21" name="Text 18"/>
-          <p:cNvSpPr txBox="1"/>
-          <p:nvPr/>
-        </p:nvSpPr>
-        <p:spPr>
-          <a:xfrm>
-            <a:off x="685800" y="5733288"/>
-            <a:ext cx="1371600" cy="237744"/>
+          <p:cNvPr id="23" name="Text 20"/>
+          <p:cNvSpPr txBox="1"/>
+          <p:nvPr/>
+        </p:nvSpPr>
+        <p:spPr>
+          <a:xfrm>
+            <a:off x="2958084" y="5715000"/>
+            <a:ext cx="795528" cy="237744"/>
           </a:xfrm>
           <a:prstGeom prst="roundRect">
             <a:avLst>
@@ -1710,7 +1770,7 @@
                 <a:ea typeface="Calibri" pitchFamily="34" charset="-122"/>
                 <a:cs typeface="Calibri" pitchFamily="34" charset="-120"/>
               </a:rPr>
-              <a:t>Cross-Border Ops</a:t>
+              <a:t>Ops Leader</a:t>
             </a:r>
             <a:endParaRPr lang="en-US" sz="950" dirty="0"/>
           </a:p>
@@ -1718,54 +1778,7 @@
       </p:sp>
       <p:sp>
         <p:nvSpPr>
-          <p:cNvPr id="22" name="Text 19"/>
-          <p:cNvSpPr txBox="1"/>
-          <p:nvPr/>
-        </p:nvSpPr>
-        <p:spPr>
-          <a:xfrm>
-            <a:off x="2130552" y="5733288"/>
-            <a:ext cx="1234440" cy="237744"/>
-          </a:xfrm>
-          <a:prstGeom prst="roundRect">
-            <a:avLst>
-              <a:gd name="adj" fmla="val 50000"/>
-            </a:avLst>
-          </a:prstGeom>
-          <a:solidFill>
-            <a:srgbClr val="1C3A63"/>
-          </a:solidFill>
-          <a:ln w="9525">
-            <a:solidFill>
-              <a:srgbClr val="2EC4B0"/>
-            </a:solidFill>
-          </a:ln>
-        </p:spPr>
-        <p:txBody>
-          <a:bodyPr wrap="square" lIns="0" tIns="0" rIns="0" bIns="0" rtlCol="0" anchor="ctr"/>
-          <a:lstStyle/>
-          <a:p>
-            <a:pPr algn="ctr" indent="0" marL="0">
-              <a:buNone/>
-            </a:pPr>
-            <a:r>
-              <a:rPr lang="en-US" sz="950" b="1" dirty="0">
-                <a:solidFill>
-                  <a:srgbClr val="FFFFFF"/>
-                </a:solidFill>
-                <a:latin typeface="Calibri" pitchFamily="34" charset="0"/>
-                <a:ea typeface="Calibri" pitchFamily="34" charset="-122"/>
-                <a:cs typeface="Calibri" pitchFamily="34" charset="-120"/>
-              </a:rPr>
-              <a:t>Nationwide P&amp;L</a:t>
-            </a:r>
-            <a:endParaRPr lang="en-US" sz="950" dirty="0"/>
-          </a:p>
-        </p:txBody>
-      </p:sp>
-      <p:sp>
-        <p:nvSpPr>
-          <p:cNvPr id="23" name="Vaibhav Kedia card"/>
+          <p:cNvPr id="24" name="Vaibhav Kedia card"/>
           <p:cNvSpPr/>
           <p:nvPr/>
         </p:nvSpPr>
@@ -1799,7 +1812,7 @@
       </p:sp>
       <p:sp>
         <p:nvSpPr>
-          <p:cNvPr id="24" name="Shape 21"/>
+          <p:cNvPr id="25" name="Shape 22"/>
           <p:cNvSpPr/>
           <p:nvPr/>
         </p:nvSpPr>
@@ -1824,7 +1837,7 @@
       </p:sp>
       <p:pic>
         <p:nvPicPr>
-          <p:cNvPr id="25" name="Image 1" descr="Photo of Vaibhav Kedia">    </p:cNvPr>
+          <p:cNvPr id="26" name="Image 1" descr="Photo of Vaibhav Kedia">    </p:cNvPr>
           <p:cNvPicPr>
             <a:picLocks noChangeAspect="1"/>
           </p:cNvPicPr>
@@ -1848,7 +1861,7 @@
       </p:pic>
       <p:sp>
         <p:nvSpPr>
-          <p:cNvPr id="26" name="Text 22"/>
+          <p:cNvPr id="27" name="Text 23"/>
           <p:cNvSpPr txBox="1"/>
           <p:nvPr/>
         </p:nvSpPr>
@@ -1879,7 +1892,7 @@
                 <a:ea typeface="Calibri" pitchFamily="34" charset="-122"/>
                 <a:cs typeface="Calibri" pitchFamily="34" charset="-120"/>
               </a:rPr>
-              <a:t>THE FINANCE GUARDIAN</a:t>
+              <a:t>LEADS FINANCE &amp; AUDIT</a:t>
             </a:r>
             <a:endParaRPr lang="en-US" sz="900" dirty="0"/>
           </a:p>
@@ -1887,7 +1900,7 @@
       </p:sp>
       <p:sp>
         <p:nvSpPr>
-          <p:cNvPr id="27" name="Text 23">
+          <p:cNvPr id="28" name="Text 24">
             <a:hlinkClick r:id="rId4" tooltip=""/>
           </p:cNvPr>
           <p:cNvSpPr txBox="1"/>
@@ -1935,7 +1948,7 @@
       </p:sp>
       <p:sp>
         <p:nvSpPr>
-          <p:cNvPr id="28" name="Text 24"/>
+          <p:cNvPr id="29" name="Text 25"/>
           <p:cNvSpPr txBox="1"/>
           <p:nvPr/>
         </p:nvSpPr>
@@ -1974,7 +1987,7 @@
       </p:sp>
       <p:sp>
         <p:nvSpPr>
-          <p:cNvPr id="29" name="Text 25"/>
+          <p:cNvPr id="30" name="Text 26"/>
           <p:cNvSpPr txBox="1"/>
           <p:nvPr/>
         </p:nvSpPr>
@@ -2013,14 +2026,94 @@
       </p:sp>
       <p:sp>
         <p:nvSpPr>
-          <p:cNvPr id="30" name="Text 26"/>
-          <p:cNvSpPr txBox="1"/>
-          <p:nvPr/>
-        </p:nvSpPr>
-        <p:spPr>
-          <a:xfrm>
-            <a:off x="4507992" y="3081528"/>
-            <a:ext cx="1545336" cy="457200"/>
+          <p:cNvPr id="31" name="Shape 27"/>
+          <p:cNvSpPr/>
+          <p:nvPr/>
+        </p:nvSpPr>
+        <p:spPr>
+          <a:xfrm>
+            <a:off x="4507992" y="3017520"/>
+            <a:ext cx="3182112" cy="566928"/>
+          </a:xfrm>
+          <a:prstGeom prst="roundRect">
+            <a:avLst>
+              <a:gd name="adj" fmla="val 12903"/>
+            </a:avLst>
+          </a:prstGeom>
+          <a:solidFill>
+            <a:srgbClr val="1C3A63"/>
+          </a:solidFill>
+          <a:ln w="12700">
+            <a:solidFill>
+              <a:srgbClr val="E07A3F"/>
+            </a:solidFill>
+            <a:prstDash val="solid"/>
+          </a:ln>
+        </p:spPr>
+      </p:sp>
+      <p:sp>
+        <p:nvSpPr>
+          <p:cNvPr id="32" name="Text 28"/>
+          <p:cNvSpPr txBox="1"/>
+          <p:nvPr/>
+        </p:nvSpPr>
+        <p:spPr>
+          <a:xfrm>
+            <a:off x="4617720" y="3063240"/>
+            <a:ext cx="2962656" cy="475488"/>
+          </a:xfrm>
+          <a:prstGeom prst="rect">
+            <a:avLst/>
+          </a:prstGeom>
+          <a:noFill/>
+          <a:ln/>
+        </p:spPr>
+        <p:txBody>
+          <a:bodyPr wrap="square" lIns="0" tIns="0" rIns="0" bIns="0" rtlCol="0" anchor="ctr"/>
+          <a:lstStyle/>
+          <a:p>
+            <a:pPr indent="0" marL="0">
+              <a:buNone/>
+            </a:pPr>
+            <a:r>
+              <a:rPr lang="en-US" sz="850" b="1" spc="100" kern="0" dirty="0">
+                <a:solidFill>
+                  <a:srgbClr val="E07A3F"/>
+                </a:solidFill>
+                <a:latin typeface="Calibri" pitchFamily="34" charset="0"/>
+                <a:ea typeface="Calibri" pitchFamily="34" charset="-122"/>
+                <a:cs typeface="Calibri" pitchFamily="34" charset="-120"/>
+              </a:rPr>
+              <a:t>AT BRIDGE NURSE  </a:t>
+            </a:r>
+            <a:pPr indent="0" marL="0">
+              <a:buNone/>
+            </a:pPr>
+            <a:r>
+              <a:rPr lang="en-US" sz="1050" i="1" dirty="0">
+                <a:solidFill>
+                  <a:srgbClr val="FFFFFF"/>
+                </a:solidFill>
+                <a:latin typeface="Calibri" pitchFamily="34" charset="0"/>
+                <a:ea typeface="Calibri" pitchFamily="34" charset="-122"/>
+                <a:cs typeface="Calibri" pitchFamily="34" charset="-120"/>
+              </a:rPr>
+              <a:t>Big 4-grade controls from day one, from a CFO who has delivered a QIP and now leads an IPO.</a:t>
+            </a:r>
+            <a:endParaRPr lang="en-US" sz="1050" dirty="0"/>
+          </a:p>
+        </p:txBody>
+      </p:sp>
+      <p:sp>
+        <p:nvSpPr>
+          <p:cNvPr id="33" name="Text 29"/>
+          <p:cNvSpPr txBox="1"/>
+          <p:nvPr/>
+        </p:nvSpPr>
+        <p:spPr>
+          <a:xfrm>
+            <a:off x="4507992" y="3675888"/>
+            <a:ext cx="1545336" cy="411480"/>
           </a:xfrm>
           <a:prstGeom prst="rect">
             <a:avLst/>
@@ -2052,14 +2145,14 @@
       </p:sp>
       <p:sp>
         <p:nvSpPr>
-          <p:cNvPr id="31" name="Text 27"/>
-          <p:cNvSpPr txBox="1"/>
-          <p:nvPr/>
-        </p:nvSpPr>
-        <p:spPr>
-          <a:xfrm>
-            <a:off x="4507992" y="3538728"/>
-            <a:ext cx="1545336" cy="329184"/>
+          <p:cNvPr id="34" name="Text 30"/>
+          <p:cNvSpPr txBox="1"/>
+          <p:nvPr/>
+        </p:nvSpPr>
+        <p:spPr>
+          <a:xfrm>
+            <a:off x="4507992" y="4087368"/>
+            <a:ext cx="1545336" cy="310896"/>
           </a:xfrm>
           <a:prstGeom prst="rect">
             <a:avLst/>
@@ -2091,14 +2184,14 @@
       </p:sp>
       <p:sp>
         <p:nvSpPr>
-          <p:cNvPr id="32" name="Text 28"/>
-          <p:cNvSpPr txBox="1"/>
-          <p:nvPr/>
-        </p:nvSpPr>
-        <p:spPr>
-          <a:xfrm>
-            <a:off x="6144768" y="3081528"/>
-            <a:ext cx="1545336" cy="457200"/>
+          <p:cNvPr id="35" name="Text 31"/>
+          <p:cNvSpPr txBox="1"/>
+          <p:nvPr/>
+        </p:nvSpPr>
+        <p:spPr>
+          <a:xfrm>
+            <a:off x="6144768" y="3675888"/>
+            <a:ext cx="1545336" cy="411480"/>
           </a:xfrm>
           <a:prstGeom prst="rect">
             <a:avLst/>
@@ -2130,14 +2223,14 @@
       </p:sp>
       <p:sp>
         <p:nvSpPr>
-          <p:cNvPr id="33" name="Text 29"/>
-          <p:cNvSpPr txBox="1"/>
-          <p:nvPr/>
-        </p:nvSpPr>
-        <p:spPr>
-          <a:xfrm>
-            <a:off x="6144768" y="3538728"/>
-            <a:ext cx="1545336" cy="329184"/>
+          <p:cNvPr id="36" name="Text 32"/>
+          <p:cNvSpPr txBox="1"/>
+          <p:nvPr/>
+        </p:nvSpPr>
+        <p:spPr>
+          <a:xfrm>
+            <a:off x="6144768" y="4087368"/>
+            <a:ext cx="1545336" cy="310896"/>
           </a:xfrm>
           <a:prstGeom prst="rect">
             <a:avLst/>
@@ -2161,7 +2254,7 @@
                 <a:ea typeface="Calibri" pitchFamily="34" charset="-122"/>
                 <a:cs typeface="Calibri" pitchFamily="34" charset="-120"/>
               </a:rPr>
-              <a:t>Fortune &amp; Sensex 30 audits led</a:t>
+              <a:t>Fortune &amp; Sensex audits led</a:t>
             </a:r>
             <a:endParaRPr lang="en-US" sz="1000" dirty="0"/>
           </a:p>
@@ -2169,13 +2262,13 @@
       </p:sp>
       <p:sp>
         <p:nvSpPr>
-          <p:cNvPr id="34" name="Text 30"/>
-          <p:cNvSpPr txBox="1"/>
-          <p:nvPr/>
-        </p:nvSpPr>
-        <p:spPr>
-          <a:xfrm>
-            <a:off x="4507992" y="3959352"/>
+          <p:cNvPr id="37" name="Text 33"/>
+          <p:cNvSpPr txBox="1"/>
+          <p:nvPr/>
+        </p:nvSpPr>
+        <p:spPr>
+          <a:xfrm>
+            <a:off x="4507992" y="4434840"/>
             <a:ext cx="3182112" cy="164592"/>
           </a:xfrm>
           <a:prstGeom prst="rect">
@@ -2200,7 +2293,7 @@
                 <a:ea typeface="Calibri" pitchFamily="34" charset="-122"/>
                 <a:cs typeface="Calibri" pitchFamily="34" charset="-120"/>
               </a:rPr>
-              <a:t>WORKED WITH</a:t>
+              <a:t>TRUSTED BY</a:t>
             </a:r>
             <a:endParaRPr lang="en-US" sz="850" dirty="0"/>
           </a:p>
@@ -2208,13 +2301,13 @@
       </p:sp>
       <p:sp>
         <p:nvSpPr>
-          <p:cNvPr id="35" name="Text 31"/>
-          <p:cNvSpPr txBox="1"/>
-          <p:nvPr/>
-        </p:nvSpPr>
-        <p:spPr>
-          <a:xfrm>
-            <a:off x="4507992" y="4123944"/>
+          <p:cNvPr id="38" name="Text 34"/>
+          <p:cNvSpPr txBox="1"/>
+          <p:nvPr/>
+        </p:nvSpPr>
+        <p:spPr>
+          <a:xfrm>
+            <a:off x="4507992" y="4590288"/>
             <a:ext cx="3182112" cy="384048"/>
           </a:xfrm>
           <a:prstGeom prst="rect">
@@ -2247,14 +2340,14 @@
       </p:sp>
       <p:sp>
         <p:nvSpPr>
-          <p:cNvPr id="36" name="Text 32"/>
-          <p:cNvSpPr txBox="1"/>
-          <p:nvPr/>
-        </p:nvSpPr>
-        <p:spPr>
-          <a:xfrm>
-            <a:off x="4507992" y="4526280"/>
-            <a:ext cx="3182112" cy="896112"/>
+          <p:cNvPr id="39" name="Text 35"/>
+          <p:cNvSpPr txBox="1"/>
+          <p:nvPr/>
+        </p:nvSpPr>
+        <p:spPr>
+          <a:xfrm>
+            <a:off x="4507992" y="4983480"/>
+            <a:ext cx="3182112" cy="676656"/>
           </a:xfrm>
           <a:prstGeom prst="rect">
             <a:avLst/>
@@ -2282,7 +2375,7 @@
                 <a:ea typeface="Calibri" pitchFamily="34" charset="-122"/>
                 <a:cs typeface="Calibri" pitchFamily="34" charset="-120"/>
               </a:rPr>
-              <a:t>Leads Big 4 audits of Fortune 500 &amp; listed companies; team of ~25</a:t>
+              <a:t>Leads Big 4 audits of Fortune Top 10 &amp; Sensex 30 companies; team of ~25</a:t>
             </a:r>
             <a:endParaRPr lang="en-US" sz="1000" dirty="0"/>
           </a:p>
@@ -2303,43 +2396,22 @@
                 <a:ea typeface="Calibri" pitchFamily="34" charset="-122"/>
                 <a:cs typeface="Calibri" pitchFamily="34" charset="-120"/>
               </a:rPr>
-              <a:t>Delivered a QIP; leads an IPO engagement</a:t>
+              <a:t>Steered a global restructuring of an e-commerce MNC; IFRS, US GAAP, SOX</a:t>
             </a:r>
             <a:endParaRPr lang="en-US" sz="1000" dirty="0"/>
           </a:p>
-          <a:p>
-            <a:pPr marL="152400" indent="-152400">
-              <a:spcAft>
-                <a:spcPts val="300"/>
-              </a:spcAft>
-              <a:buSzPct val="100000"/>
-              <a:buChar char="•"/>
-            </a:pPr>
-            <a:r>
-              <a:rPr lang="en-US" sz="1000" dirty="0">
-                <a:solidFill>
-                  <a:srgbClr val="B9C7DD"/>
-                </a:solidFill>
-                <a:latin typeface="Calibri" pitchFamily="34" charset="0"/>
-                <a:ea typeface="Calibri" pitchFamily="34" charset="-122"/>
-                <a:cs typeface="Calibri" pitchFamily="34" charset="-120"/>
-              </a:rPr>
-              <a:t>Steered global restructuring of an e-commerce MNC (IFRS, US GAAP, SOX)</a:t>
-            </a:r>
-            <a:endParaRPr lang="en-US" sz="1000" dirty="0"/>
-          </a:p>
-        </p:txBody>
-      </p:sp>
-      <p:sp>
-        <p:nvSpPr>
-          <p:cNvPr id="37" name="Text 33"/>
-          <p:cNvSpPr txBox="1"/>
-          <p:nvPr/>
-        </p:nvSpPr>
-        <p:spPr>
-          <a:xfrm>
-            <a:off x="4507992" y="5458968"/>
-            <a:ext cx="1303020" cy="237744"/>
+        </p:txBody>
+      </p:sp>
+      <p:sp>
+        <p:nvSpPr>
+          <p:cNvPr id="40" name="Text 36"/>
+          <p:cNvSpPr txBox="1"/>
+          <p:nvPr/>
+        </p:nvSpPr>
+        <p:spPr>
+          <a:xfrm>
+            <a:off x="4507992" y="5715000"/>
+            <a:ext cx="1092708" cy="237744"/>
           </a:xfrm>
           <a:prstGeom prst="roundRect">
             <a:avLst>
@@ -2379,14 +2451,14 @@
       </p:sp>
       <p:sp>
         <p:nvSpPr>
-          <p:cNvPr id="38" name="Text 34"/>
-          <p:cNvSpPr txBox="1"/>
-          <p:nvPr/>
-        </p:nvSpPr>
-        <p:spPr>
-          <a:xfrm>
-            <a:off x="5884164" y="5458968"/>
-            <a:ext cx="1028700" cy="237744"/>
+          <p:cNvPr id="41" name="Text 37"/>
+          <p:cNvSpPr txBox="1"/>
+          <p:nvPr/>
+        </p:nvSpPr>
+        <p:spPr>
+          <a:xfrm>
+            <a:off x="5673852" y="5715000"/>
+            <a:ext cx="854964" cy="237744"/>
           </a:xfrm>
           <a:prstGeom prst="roundRect">
             <a:avLst>
@@ -2426,14 +2498,14 @@
       </p:sp>
       <p:sp>
         <p:nvSpPr>
-          <p:cNvPr id="39" name="Text 35"/>
-          <p:cNvSpPr txBox="1"/>
-          <p:nvPr/>
-        </p:nvSpPr>
-        <p:spPr>
-          <a:xfrm>
-            <a:off x="4507992" y="5733288"/>
-            <a:ext cx="1714500" cy="237744"/>
+          <p:cNvPr id="42" name="Text 38"/>
+          <p:cNvSpPr txBox="1"/>
+          <p:nvPr/>
+        </p:nvSpPr>
+        <p:spPr>
+          <a:xfrm>
+            <a:off x="6601968" y="5715000"/>
+            <a:ext cx="736092" cy="237744"/>
           </a:xfrm>
           <a:prstGeom prst="roundRect">
             <a:avLst>
@@ -2465,7 +2537,7 @@
                 <a:ea typeface="Calibri" pitchFamily="34" charset="-122"/>
                 <a:cs typeface="Calibri" pitchFamily="34" charset="-120"/>
               </a:rPr>
-              <a:t>IPO &amp; Capital Markets</a:t>
+              <a:t>IPO Ready</a:t>
             </a:r>
             <a:endParaRPr lang="en-US" sz="950" dirty="0"/>
           </a:p>
@@ -2473,7 +2545,7 @@
       </p:sp>
       <p:sp>
         <p:nvSpPr>
-          <p:cNvPr id="40" name="Rahul Luthra card"/>
+          <p:cNvPr id="43" name="Rahul Luthra card"/>
           <p:cNvSpPr/>
           <p:nvPr/>
         </p:nvSpPr>
@@ -2507,7 +2579,7 @@
       </p:sp>
       <p:sp>
         <p:nvSpPr>
-          <p:cNvPr id="41" name="Shape 37"/>
+          <p:cNvPr id="44" name="Shape 40"/>
           <p:cNvSpPr/>
           <p:nvPr/>
         </p:nvSpPr>
@@ -2532,7 +2604,7 @@
       </p:sp>
       <p:pic>
         <p:nvPicPr>
-          <p:cNvPr id="42" name="Image 2" descr="Photo of Rahul Luthra">    </p:cNvPr>
+          <p:cNvPr id="45" name="Image 2" descr="Photo of Rahul Luthra">    </p:cNvPr>
           <p:cNvPicPr>
             <a:picLocks noChangeAspect="1"/>
           </p:cNvPicPr>
@@ -2556,7 +2628,7 @@
       </p:pic>
       <p:sp>
         <p:nvSpPr>
-          <p:cNvPr id="43" name="Text 38"/>
+          <p:cNvPr id="46" name="Text 41"/>
           <p:cNvSpPr txBox="1"/>
           <p:nvPr/>
         </p:nvSpPr>
@@ -2587,7 +2659,7 @@
                 <a:ea typeface="Calibri" pitchFamily="34" charset="-122"/>
                 <a:cs typeface="Calibri" pitchFamily="34" charset="-120"/>
               </a:rPr>
-              <a:t>THE 0→1 BUILDER</a:t>
+              <a:t>LEADS GROWTH &amp; LAUNCH</a:t>
             </a:r>
             <a:endParaRPr lang="en-US" sz="900" dirty="0"/>
           </a:p>
@@ -2595,7 +2667,7 @@
       </p:sp>
       <p:sp>
         <p:nvSpPr>
-          <p:cNvPr id="44" name="Text 39">
+          <p:cNvPr id="47" name="Text 42">
             <a:hlinkClick r:id="rId6" tooltip=""/>
           </p:cNvPr>
           <p:cNvSpPr txBox="1"/>
@@ -2643,7 +2715,7 @@
       </p:sp>
       <p:sp>
         <p:nvSpPr>
-          <p:cNvPr id="45" name="Text 40"/>
+          <p:cNvPr id="48" name="Text 43"/>
           <p:cNvSpPr txBox="1"/>
           <p:nvPr/>
         </p:nvSpPr>
@@ -2682,7 +2754,7 @@
       </p:sp>
       <p:sp>
         <p:nvSpPr>
-          <p:cNvPr id="46" name="Text 41"/>
+          <p:cNvPr id="49" name="Text 44"/>
           <p:cNvSpPr txBox="1"/>
           <p:nvPr/>
         </p:nvSpPr>
@@ -2721,14 +2793,94 @@
       </p:sp>
       <p:sp>
         <p:nvSpPr>
-          <p:cNvPr id="47" name="Text 42"/>
-          <p:cNvSpPr txBox="1"/>
-          <p:nvPr/>
-        </p:nvSpPr>
-        <p:spPr>
-          <a:xfrm>
-            <a:off x="8330184" y="3081528"/>
-            <a:ext cx="1545336" cy="457200"/>
+          <p:cNvPr id="50" name="Shape 45"/>
+          <p:cNvSpPr/>
+          <p:nvPr/>
+        </p:nvSpPr>
+        <p:spPr>
+          <a:xfrm>
+            <a:off x="8330184" y="3017520"/>
+            <a:ext cx="3182112" cy="566928"/>
+          </a:xfrm>
+          <a:prstGeom prst="roundRect">
+            <a:avLst>
+              <a:gd name="adj" fmla="val 12903"/>
+            </a:avLst>
+          </a:prstGeom>
+          <a:solidFill>
+            <a:srgbClr val="1C3A63"/>
+          </a:solidFill>
+          <a:ln w="12700">
+            <a:solidFill>
+              <a:srgbClr val="6FB2F0"/>
+            </a:solidFill>
+            <a:prstDash val="solid"/>
+          </a:ln>
+        </p:spPr>
+      </p:sp>
+      <p:sp>
+        <p:nvSpPr>
+          <p:cNvPr id="51" name="Text 46"/>
+          <p:cNvSpPr txBox="1"/>
+          <p:nvPr/>
+        </p:nvSpPr>
+        <p:spPr>
+          <a:xfrm>
+            <a:off x="8439912" y="3063240"/>
+            <a:ext cx="2962656" cy="475488"/>
+          </a:xfrm>
+          <a:prstGeom prst="rect">
+            <a:avLst/>
+          </a:prstGeom>
+          <a:noFill/>
+          <a:ln/>
+        </p:spPr>
+        <p:txBody>
+          <a:bodyPr wrap="square" lIns="0" tIns="0" rIns="0" bIns="0" rtlCol="0" anchor="ctr"/>
+          <a:lstStyle/>
+          <a:p>
+            <a:pPr indent="0" marL="0">
+              <a:buNone/>
+            </a:pPr>
+            <a:r>
+              <a:rPr lang="en-US" sz="850" b="1" spc="100" kern="0" dirty="0">
+                <a:solidFill>
+                  <a:srgbClr val="6FB2F0"/>
+                </a:solidFill>
+                <a:latin typeface="Calibri" pitchFamily="34" charset="0"/>
+                <a:ea typeface="Calibri" pitchFamily="34" charset="-122"/>
+                <a:cs typeface="Calibri" pitchFamily="34" charset="-120"/>
+              </a:rPr>
+              <a:t>AT BRIDGE NURSE  </a:t>
+            </a:r>
+            <a:pPr indent="0" marL="0">
+              <a:buNone/>
+            </a:pPr>
+            <a:r>
+              <a:rPr lang="en-US" sz="1050" i="1" dirty="0">
+                <a:solidFill>
+                  <a:srgbClr val="FFFFFF"/>
+                </a:solidFill>
+                <a:latin typeface="Calibri" pitchFamily="34" charset="0"/>
+                <a:ea typeface="Calibri" pitchFamily="34" charset="-122"/>
+                <a:cs typeface="Calibri" pitchFamily="34" charset="-120"/>
+              </a:rPr>
+              <a:t>Launches new cities and nurse cohorts the way Swiggy was launched in 20+ cities: fast and at scale.</a:t>
+            </a:r>
+            <a:endParaRPr lang="en-US" sz="1050" dirty="0"/>
+          </a:p>
+        </p:txBody>
+      </p:sp>
+      <p:sp>
+        <p:nvSpPr>
+          <p:cNvPr id="52" name="Text 47"/>
+          <p:cNvSpPr txBox="1"/>
+          <p:nvPr/>
+        </p:nvSpPr>
+        <p:spPr>
+          <a:xfrm>
+            <a:off x="8330184" y="3675888"/>
+            <a:ext cx="1545336" cy="411480"/>
           </a:xfrm>
           <a:prstGeom prst="rect">
             <a:avLst/>
@@ -2760,14 +2912,14 @@
       </p:sp>
       <p:sp>
         <p:nvSpPr>
-          <p:cNvPr id="48" name="Text 43"/>
-          <p:cNvSpPr txBox="1"/>
-          <p:nvPr/>
-        </p:nvSpPr>
-        <p:spPr>
-          <a:xfrm>
-            <a:off x="8330184" y="3538728"/>
-            <a:ext cx="1545336" cy="329184"/>
+          <p:cNvPr id="53" name="Text 48"/>
+          <p:cNvSpPr txBox="1"/>
+          <p:nvPr/>
+        </p:nvSpPr>
+        <p:spPr>
+          <a:xfrm>
+            <a:off x="8330184" y="4087368"/>
+            <a:ext cx="1545336" cy="310896"/>
           </a:xfrm>
           <a:prstGeom prst="rect">
             <a:avLst/>
@@ -2791,7 +2943,7 @@
                 <a:ea typeface="Calibri" pitchFamily="34" charset="-122"/>
                 <a:cs typeface="Calibri" pitchFamily="34" charset="-120"/>
               </a:rPr>
-              <a:t>gig workers onboarded at Swiggy</a:t>
+              <a:t>gig workers onboarded</a:t>
             </a:r>
             <a:endParaRPr lang="en-US" sz="1000" dirty="0"/>
           </a:p>
@@ -2799,14 +2951,14 @@
       </p:sp>
       <p:sp>
         <p:nvSpPr>
-          <p:cNvPr id="49" name="Text 44"/>
-          <p:cNvSpPr txBox="1"/>
-          <p:nvPr/>
-        </p:nvSpPr>
-        <p:spPr>
-          <a:xfrm>
-            <a:off x="9966960" y="3081528"/>
-            <a:ext cx="1545336" cy="457200"/>
+          <p:cNvPr id="54" name="Text 49"/>
+          <p:cNvSpPr txBox="1"/>
+          <p:nvPr/>
+        </p:nvSpPr>
+        <p:spPr>
+          <a:xfrm>
+            <a:off x="9966960" y="3675888"/>
+            <a:ext cx="1545336" cy="411480"/>
           </a:xfrm>
           <a:prstGeom prst="rect">
             <a:avLst/>
@@ -2838,14 +2990,14 @@
       </p:sp>
       <p:sp>
         <p:nvSpPr>
-          <p:cNvPr id="50" name="Text 45"/>
-          <p:cNvSpPr txBox="1"/>
-          <p:nvPr/>
-        </p:nvSpPr>
-        <p:spPr>
-          <a:xfrm>
-            <a:off x="9966960" y="3538728"/>
-            <a:ext cx="1545336" cy="329184"/>
+          <p:cNvPr id="55" name="Text 50"/>
+          <p:cNvSpPr txBox="1"/>
+          <p:nvPr/>
+        </p:nvSpPr>
+        <p:spPr>
+          <a:xfrm>
+            <a:off x="9966960" y="4087368"/>
+            <a:ext cx="1545336" cy="310896"/>
           </a:xfrm>
           <a:prstGeom prst="rect">
             <a:avLst/>
@@ -2877,13 +3029,13 @@
       </p:sp>
       <p:sp>
         <p:nvSpPr>
-          <p:cNvPr id="51" name="Text 46"/>
-          <p:cNvSpPr txBox="1"/>
-          <p:nvPr/>
-        </p:nvSpPr>
-        <p:spPr>
-          <a:xfrm>
-            <a:off x="8330184" y="3959352"/>
+          <p:cNvPr id="56" name="Text 51"/>
+          <p:cNvSpPr txBox="1"/>
+          <p:nvPr/>
+        </p:nvSpPr>
+        <p:spPr>
+          <a:xfrm>
+            <a:off x="8330184" y="4434840"/>
             <a:ext cx="3182112" cy="164592"/>
           </a:xfrm>
           <a:prstGeom prst="rect">
@@ -2916,13 +3068,13 @@
       </p:sp>
       <p:sp>
         <p:nvSpPr>
-          <p:cNvPr id="52" name="Text 47"/>
-          <p:cNvSpPr txBox="1"/>
-          <p:nvPr/>
-        </p:nvSpPr>
-        <p:spPr>
-          <a:xfrm>
-            <a:off x="8330184" y="4123944"/>
+          <p:cNvPr id="57" name="Text 52"/>
+          <p:cNvSpPr txBox="1"/>
+          <p:nvPr/>
+        </p:nvSpPr>
+        <p:spPr>
+          <a:xfrm>
+            <a:off x="8330184" y="4590288"/>
             <a:ext cx="3182112" cy="384048"/>
           </a:xfrm>
           <a:prstGeom prst="rect">
@@ -2955,14 +3107,14 @@
       </p:sp>
       <p:sp>
         <p:nvSpPr>
-          <p:cNvPr id="53" name="Text 48"/>
-          <p:cNvSpPr txBox="1"/>
-          <p:nvPr/>
-        </p:nvSpPr>
-        <p:spPr>
-          <a:xfrm>
-            <a:off x="8330184" y="4526280"/>
-            <a:ext cx="3182112" cy="896112"/>
+          <p:cNvPr id="58" name="Text 53"/>
+          <p:cNvSpPr txBox="1"/>
+          <p:nvPr/>
+        </p:nvSpPr>
+        <p:spPr>
+          <a:xfrm>
+            <a:off x="8330184" y="4983480"/>
+            <a:ext cx="3182112" cy="676656"/>
           </a:xfrm>
           <a:prstGeom prst="rect">
             <a:avLst/>
@@ -2990,7 +3142,7 @@
                 <a:ea typeface="Calibri" pitchFamily="34" charset="-122"/>
                 <a:cs typeface="Calibri" pitchFamily="34" charset="-120"/>
               </a:rPr>
-              <a:t>Scaled two businesses from zero as a 2x founder</a:t>
+              <a:t>2x founder: scaled two businesses from zero</a:t>
             </a:r>
             <a:endParaRPr lang="en-US" sz="1000" dirty="0"/>
           </a:p>
@@ -3011,43 +3163,22 @@
                 <a:ea typeface="Calibri" pitchFamily="34" charset="-122"/>
                 <a:cs typeface="Calibri" pitchFamily="34" charset="-120"/>
               </a:rPr>
-              <a:t>Mitr.work: 400+ delivery partners a month for Swiggy, Zomato &amp; Zepto</a:t>
+              <a:t>Mitr.work: 400+ delivery partners onboarded every month for Swiggy, Zomato &amp; Zepto</a:t>
             </a:r>
             <a:endParaRPr lang="en-US" sz="1000" dirty="0"/>
           </a:p>
-          <a:p>
-            <a:pPr marL="152400" indent="-152400">
-              <a:spcAft>
-                <a:spcPts val="300"/>
-              </a:spcAft>
-              <a:buSzPct val="100000"/>
-              <a:buChar char="•"/>
-            </a:pPr>
-            <a:r>
-              <a:rPr lang="en-US" sz="1000" dirty="0">
-                <a:solidFill>
-                  <a:srgbClr val="B9C7DD"/>
-                </a:solidFill>
-                <a:latin typeface="Calibri" pitchFamily="34" charset="0"/>
-                <a:ea typeface="Calibri" pitchFamily="34" charset="-122"/>
-                <a:cs typeface="Calibri" pitchFamily="34" charset="-120"/>
-              </a:rPr>
-              <a:t>Built North India staffing at Abacus from scratch to 200+ on payroll</a:t>
-            </a:r>
-            <a:endParaRPr lang="en-US" sz="1000" dirty="0"/>
-          </a:p>
-        </p:txBody>
-      </p:sp>
-      <p:sp>
-        <p:nvSpPr>
-          <p:cNvPr id="54" name="Text 49"/>
-          <p:cNvSpPr txBox="1"/>
-          <p:nvPr/>
-        </p:nvSpPr>
-        <p:spPr>
-          <a:xfrm>
-            <a:off x="8330184" y="5458968"/>
-            <a:ext cx="1028700" cy="237744"/>
+        </p:txBody>
+      </p:sp>
+      <p:sp>
+        <p:nvSpPr>
+          <p:cNvPr id="59" name="Text 54"/>
+          <p:cNvSpPr txBox="1"/>
+          <p:nvPr/>
+        </p:nvSpPr>
+        <p:spPr>
+          <a:xfrm>
+            <a:off x="8330184" y="5715000"/>
+            <a:ext cx="854964" cy="237744"/>
           </a:xfrm>
           <a:prstGeom prst="roundRect">
             <a:avLst>
@@ -3087,14 +3218,14 @@
       </p:sp>
       <p:sp>
         <p:nvSpPr>
-          <p:cNvPr id="55" name="Text 50"/>
-          <p:cNvSpPr txBox="1"/>
-          <p:nvPr/>
-        </p:nvSpPr>
-        <p:spPr>
-          <a:xfrm>
-            <a:off x="9432036" y="5458968"/>
-            <a:ext cx="480060" cy="237744"/>
+          <p:cNvPr id="60" name="Text 55"/>
+          <p:cNvSpPr txBox="1"/>
+          <p:nvPr/>
+        </p:nvSpPr>
+        <p:spPr>
+          <a:xfrm>
+            <a:off x="9258300" y="5715000"/>
+            <a:ext cx="379476" cy="237744"/>
           </a:xfrm>
           <a:prstGeom prst="roundRect">
             <a:avLst>
@@ -3134,14 +3265,14 @@
       </p:sp>
       <p:sp>
         <p:nvSpPr>
-          <p:cNvPr id="56" name="Text 51"/>
-          <p:cNvSpPr txBox="1"/>
-          <p:nvPr/>
-        </p:nvSpPr>
-        <p:spPr>
-          <a:xfrm>
-            <a:off x="9985248" y="5458968"/>
-            <a:ext cx="1508760" cy="237744"/>
+          <p:cNvPr id="61" name="Text 56"/>
+          <p:cNvSpPr txBox="1"/>
+          <p:nvPr/>
+        </p:nvSpPr>
+        <p:spPr>
+          <a:xfrm>
+            <a:off x="9710928" y="5715000"/>
+            <a:ext cx="1271016" cy="237744"/>
           </a:xfrm>
           <a:prstGeom prst="roundRect">
             <a:avLst>
@@ -3181,7 +3312,7 @@
       </p:sp>
       <p:sp>
         <p:nvSpPr>
-          <p:cNvPr id="57" name="Text 52"/>
+          <p:cNvPr id="62" name="Text 57"/>
           <p:cNvSpPr txBox="1"/>
           <p:nvPr/>
         </p:nvSpPr>
@@ -3212,7 +3343,7 @@
                 <a:ea typeface="Calibri" pitchFamily="34" charset="-122"/>
                 <a:cs typeface="Calibri" pitchFamily="34" charset="-120"/>
               </a:rPr>
-              <a:t>Hiring priorities at close: </a:t>
+              <a:t>Next hires at close: </a:t>
             </a:r>
             <a:pPr indent="0" marL="0">
               <a:buNone/>
@@ -3226,7 +3357,7 @@
                 <a:ea typeface="Calibri" pitchFamily="34" charset="-122"/>
                 <a:cs typeface="Calibri" pitchFamily="34" charset="-120"/>
               </a:rPr>
-              <a:t>technology / AI, nurse education and corridor operations. Discussions under way; no offers rolled out yet.</a:t>
+              <a:t>technology / AI, nurse education and corridor operations leaders. Discussions under way; no offers rolled out yet.</a:t>
             </a:r>
             <a:endParaRPr lang="en-US" sz="1050" dirty="0"/>
           </a:p>
@@ -3234,7 +3365,7 @@
       </p:sp>
       <p:sp>
         <p:nvSpPr>
-          <p:cNvPr id="58" name="Shape 53"/>
+          <p:cNvPr id="63" name="Shape 58"/>
           <p:cNvSpPr/>
           <p:nvPr/>
         </p:nvSpPr>
@@ -3261,7 +3392,7 @@
       </p:sp>
       <p:pic>
         <p:nvPicPr>
-          <p:cNvPr id="59" name="Image 3" descr="Triple Arrow Global logo">    </p:cNvPr>
+          <p:cNvPr id="64" name="Image 3" descr="Triple Arrow Global logo">    </p:cNvPr>
           <p:cNvPicPr>
             <a:picLocks noChangeAspect="1"/>
           </p:cNvPicPr>
@@ -3285,7 +3416,7 @@
       </p:pic>
       <p:sp>
         <p:nvSpPr>
-          <p:cNvPr id="60" name="Text 54"/>
+          <p:cNvPr id="65" name="Text 59"/>
           <p:cNvSpPr txBox="1"/>
           <p:nvPr/>
         </p:nvSpPr>
@@ -3324,7 +3455,7 @@
       </p:sp>
       <p:sp>
         <p:nvSpPr>
-          <p:cNvPr id="61" name="Text 55"/>
+          <p:cNvPr id="66" name="Text 60"/>
           <p:cNvSpPr txBox="1"/>
           <p:nvPr/>
         </p:nvSpPr>

</xml_diff>

<commit_message>
Founder slide: reframe as pre-launch team the raise will fund
Co-Authored-By: Claude Opus 5.5 <noreply@anthropic.com>
Claude-Session: https://claude.ai/code/session_01StTNeBEfEL1qu9q7jAwWu4
</commit_message>
<xml_diff>
--- a/Founder_Slide_v2.pptx
+++ b/Founder_Slide_v2.pptx
@@ -502,7 +502,7 @@
           <a:p>
             <a:r>
               <a:rPr lang="en-US" dirty="0"/>
-              <a:t>Message: this team has already done the hardest parts of Bridge Nurse: recruiting and deploying a workforce at scale (21,000+ between Sutanu and Rahul), opening healthcare corridors abroad (Sutanu, RG Medicare: Bangladesh and Oman), and running Big 4-grade finance and governance (Vaibhav). Nurse education is the gap, which is why it leads the hiring plan.
+              <a:t>Message: Bridge Nurse is pre-launch, and this raise funds the build. The team has already done the hard parts elsewhere: recruiting and deploying a workforce at scale (21,000+ between Sutanu and Rahul), opening healthcare corridors abroad (Sutanu, RG Medicare: Bangladesh and Oman), and running Big 4-grade finance and governance (Vaibhav). Nurse education is the gap, which is why it leads the hiring plan at close.
 Founder roles and backgrounds as represented by management. Founder names link to their professional profiles.
 Sutanu Dutta (19 years; ex-Truxapp, Rivigo, HT Media, Peel Works; 1x founder) and Rahul Luthra (9 years; ex-Swiggy; 2x founder) are full-time. Vaibhav Kedia joins full-time at close and is a Director at EY until then. Senior technology / AI, nurse-education and operations candidates are in discussion. No offers have been accepted.
 Sources: each founder's résumé or professional profile, supplied by the founder. Not independently verified. Sutanu's rupee figures at ₹95/$: staffing revenue ₹20 Cr to ₹106 Cr ($2M to $11M, 5.3×); ₹150 Cr of contracted value ($16M); ₹240 Cr distribution P&amp;L ($25M). Vaibhav's 19 years at EY include 3 years as an intern; clients include Amazon, Airtel, ITC, Siemens, Intel, Epson and Happiest Minds. Rahul's 10,000+ onboarding and 98.6% serviceability are from his Swiggy role (2019–2023).</a:t>
@@ -911,7 +911,7 @@
                 <a:ea typeface="Calibri" pitchFamily="34" charset="-122"/>
                 <a:cs typeface="Calibri" pitchFamily="34" charset="-120"/>
               </a:rPr>
-              <a:t>WHY THIS TEAM WINS AT BRIDGE NURSE</a:t>
+              <a:t>THE TEAM BUILDING BRIDGE NURSE</a:t>
             </a:r>
             <a:endParaRPr lang="en-US" sz="1100" dirty="0"/>
           </a:p>
@@ -950,7 +950,7 @@
                 <a:ea typeface="Georgia" pitchFamily="34" charset="-122"/>
                 <a:cs typeface="Georgia" pitchFamily="34" charset="-120"/>
               </a:rPr>
-              <a:t>We have already done</a:t>
+              <a:t>We’ve done it before.</a:t>
             </a:r>
             <a:pPr indent="0" marL="0">
               <a:buNone/>
@@ -964,7 +964,7 @@
                 <a:ea typeface="Georgia" pitchFamily="34" charset="-122"/>
                 <a:cs typeface="Georgia" pitchFamily="34" charset="-120"/>
               </a:rPr>
-              <a:t> the hardest parts of Bridge Nurse</a:t>
+              <a:t> Now we build Bridge Nurse.</a:t>
             </a:r>
             <a:endParaRPr lang="en-US" sz="3000" dirty="0"/>
           </a:p>
@@ -1003,7 +1003,7 @@
                 <a:ea typeface="Calibri" pitchFamily="34" charset="-122"/>
                 <a:cs typeface="Calibri" pitchFamily="34" charset="-120"/>
               </a:rPr>
-              <a:t>21,000+ workers recruited and deployed. Healthcare corridors opened abroad. Fortune Top 10 audits led. Now we do it for nurses.</a:t>
+              <a:t>21,000+ workers deployed. Healthcare markets opened abroad. Fortune Top 10 audits led. This raise puts that playbook to work for nurses.</a:t>
             </a:r>
             <a:endParaRPr lang="en-US" sz="1400" dirty="0"/>
           </a:p>
@@ -1331,7 +1331,7 @@
                 <a:ea typeface="Calibri" pitchFamily="34" charset="-122"/>
                 <a:cs typeface="Calibri" pitchFamily="34" charset="-120"/>
               </a:rPr>
-              <a:t>Has built a workforce engine and healthcare corridors abroad. Now runs both for Bridge Nurse.</a:t>
+              <a:t>Will build the nurse pipeline and overseas corridors, drawing on 11,000+ deployments and RG Medicare.</a:t>
             </a:r>
             <a:endParaRPr lang="en-US" sz="1050" dirty="0"/>
           </a:p>
@@ -2098,7 +2098,7 @@
                 <a:ea typeface="Calibri" pitchFamily="34" charset="-122"/>
                 <a:cs typeface="Calibri" pitchFamily="34" charset="-120"/>
               </a:rPr>
-              <a:t>Big 4-grade controls from day one, from a CFO who has delivered a QIP and now leads an IPO.</a:t>
+              <a:t>Will put Big 4-grade controls in place from day one: a CFO who has delivered a QIP and leads an IPO.</a:t>
             </a:r>
             <a:endParaRPr lang="en-US" sz="1050" dirty="0"/>
           </a:p>
@@ -2865,7 +2865,7 @@
                 <a:ea typeface="Calibri" pitchFamily="34" charset="-122"/>
                 <a:cs typeface="Calibri" pitchFamily="34" charset="-120"/>
               </a:rPr>
-              <a:t>Launches new cities and nurse cohorts the way Swiggy was launched in 20+ cities: fast and at scale.</a:t>
+              <a:t>Will launch each new city and nurse cohort with the playbook behind 20+ Swiggy city launches.</a:t>
             </a:r>
             <a:endParaRPr lang="en-US" sz="1050" dirty="0"/>
           </a:p>

</xml_diff>